<commit_message>
docs: exec deck — title slide matches README framing; closing slide is a real closure
Co-Authored-By: Claude Opus 4.7 <noreply@anthropic.com>
</commit_message>
<xml_diff>
--- a/docs/RuriSkry-Exec-Deck.pptx
+++ b/docs/RuriSkry-Exec-Deck.pptx
@@ -2137,8 +2137,8 @@
         </p:blipFill>
         <p:spPr>
           <a:xfrm>
-            <a:off x="5638648" y="1645920"/>
-            <a:ext cx="914400" cy="914400"/>
+            <a:off x="5684368" y="1234440"/>
+            <a:ext cx="822960" cy="822960"/>
           </a:xfrm>
           <a:prstGeom prst="rect">
             <a:avLst/>
@@ -2153,7 +2153,7 @@
         </p:nvSpPr>
         <p:spPr>
           <a:xfrm>
-            <a:off x="0" y="2743200"/>
+            <a:off x="0" y="2240280"/>
             <a:ext cx="12191695" cy="914400"/>
           </a:xfrm>
           <a:prstGeom prst="rect">
@@ -2170,7 +2170,7 @@
               <a:buNone/>
             </a:pPr>
             <a:r>
-              <a:rPr lang="en-US" sz="7200" b="1" i="1" dirty="0">
+              <a:rPr lang="en-US" sz="6800" b="1" i="1" dirty="0">
                 <a:solidFill>
                   <a:srgbClr val="FFFFFF"/>
                 </a:solidFill>
@@ -2180,7 +2180,7 @@
               </a:rPr>
               <a:t>RuriSkry</a:t>
             </a:r>
-            <a:endParaRPr lang="en-US" sz="7200" dirty="0"/>
+            <a:endParaRPr lang="en-US" sz="6800" dirty="0"/>
           </a:p>
         </p:txBody>
       </p:sp>
@@ -2192,8 +2192,8 @@
         </p:nvSpPr>
         <p:spPr>
           <a:xfrm>
-            <a:off x="0" y="3840480"/>
-            <a:ext cx="12191695" cy="1097280"/>
+            <a:off x="0" y="3337560"/>
+            <a:ext cx="12191695" cy="1280160"/>
           </a:xfrm>
           <a:prstGeom prst="rect">
             <a:avLst/>
@@ -2217,7 +2217,7 @@
                 <a:ea typeface="Georgia" pitchFamily="34" charset="-122"/>
                 <a:cs typeface="Georgia" pitchFamily="34" charset="-120"/>
               </a:rPr>
-              <a:t>An AI Change Advisory Board</a:t>
+              <a:t>Azure AI Cloud Ops Agents,</a:t>
             </a:r>
             <a:endParaRPr lang="en-US" sz="2600" dirty="0"/>
           </a:p>
@@ -2234,7 +2234,7 @@
                 <a:ea typeface="Georgia" pitchFamily="34" charset="-122"/>
                 <a:cs typeface="Georgia" pitchFamily="34" charset="-120"/>
               </a:rPr>
-              <a:t>for Autonomous Cloud Agents</a:t>
+              <a:t>Governed by an AI Change Advisory Board</a:t>
             </a:r>
             <a:endParaRPr lang="en-US" sz="2600" dirty="0"/>
           </a:p>
@@ -2248,7 +2248,71 @@
         </p:nvSpPr>
         <p:spPr>
           <a:xfrm>
-            <a:off x="0" y="5669280"/>
+            <a:off x="0" y="4800600"/>
+            <a:ext cx="12191695" cy="457200"/>
+          </a:xfrm>
+          <a:prstGeom prst="rect">
+            <a:avLst/>
+          </a:prstGeom>
+          <a:noFill/>
+          <a:ln/>
+        </p:spPr>
+        <p:txBody>
+          <a:bodyPr wrap="square" rtlCol="0" anchor="ctr"/>
+          <a:lstStyle/>
+          <a:p>
+            <a:pPr algn="ctr" indent="0" marL="0">
+              <a:buNone/>
+            </a:pPr>
+            <a:r>
+              <a:rPr lang="en-US" sz="1700" i="1" dirty="0">
+                <a:solidFill>
+                  <a:srgbClr val="CBD5E1"/>
+                </a:solidFill>
+                <a:latin typeface="Georgia" pitchFamily="34" charset="0"/>
+                <a:ea typeface="Georgia" pitchFamily="34" charset="-122"/>
+                <a:cs typeface="Georgia" pitchFamily="34" charset="-120"/>
+              </a:rPr>
+              <a:t>AI agents propose the fix. An AI Change Advisory Board decides if it ships.</a:t>
+            </a:r>
+            <a:endParaRPr lang="en-US" sz="1700" dirty="0"/>
+          </a:p>
+        </p:txBody>
+      </p:sp>
+      <p:sp>
+        <p:nvSpPr>
+          <p:cNvPr id="6" name="Shape 3"/>
+          <p:cNvSpPr/>
+          <p:nvPr/>
+        </p:nvSpPr>
+        <p:spPr>
+          <a:xfrm>
+            <a:off x="6031840" y="5486400"/>
+            <a:ext cx="128016" cy="128016"/>
+          </a:xfrm>
+          <a:prstGeom prst="ellipse">
+            <a:avLst/>
+          </a:prstGeom>
+          <a:solidFill>
+            <a:srgbClr val="F59E0B"/>
+          </a:solidFill>
+          <a:ln w="12700">
+            <a:solidFill>
+              <a:srgbClr val="F59E0B"/>
+            </a:solidFill>
+            <a:prstDash val="solid"/>
+          </a:ln>
+        </p:spPr>
+      </p:sp>
+      <p:sp>
+        <p:nvSpPr>
+          <p:cNvPr id="7" name="Text 4"/>
+          <p:cNvSpPr/>
+          <p:nvPr/>
+        </p:nvSpPr>
+        <p:spPr>
+          <a:xfrm>
+            <a:off x="0" y="5806440"/>
             <a:ext cx="12191695" cy="274320"/>
           </a:xfrm>
           <a:prstGeom prst="rect">
@@ -2265,17 +2329,17 @@
               <a:buNone/>
             </a:pPr>
             <a:r>
-              <a:rPr lang="en-US" sz="1400" i="1" dirty="0">
-                <a:solidFill>
-                  <a:srgbClr val="CBD5E1"/>
+              <a:rPr lang="en-US" sz="1300" i="1" dirty="0">
+                <a:solidFill>
+                  <a:srgbClr val="94A3B8"/>
                 </a:solidFill>
                 <a:latin typeface="Calibri" pitchFamily="34" charset="0"/>
                 <a:ea typeface="Calibri" pitchFamily="34" charset="-122"/>
                 <a:cs typeface="Calibri" pitchFamily="34" charset="-120"/>
               </a:rPr>
-              <a:t>Azure-native · Open source · Production-grade</a:t>
-            </a:r>
-            <a:endParaRPr lang="en-US" sz="1400" dirty="0"/>
+              <a:t>Azure-native · Open source · Hackathon-born, production-architected</a:t>
+            </a:r>
+            <a:endParaRPr lang="en-US" sz="1300" dirty="0"/>
           </a:p>
         </p:txBody>
       </p:sp>
@@ -6343,8 +6407,8 @@
         </p:nvSpPr>
         <p:spPr>
           <a:xfrm>
-            <a:off x="0" y="1188720"/>
-            <a:ext cx="12191695" cy="914400"/>
+            <a:off x="0" y="1097280"/>
+            <a:ext cx="12191695" cy="548640"/>
           </a:xfrm>
           <a:prstGeom prst="rect">
             <a:avLst/>
@@ -6360,9 +6424,9 @@
               <a:buNone/>
             </a:pPr>
             <a:r>
-              <a:rPr lang="en-US" sz="4800" i="1" dirty="0">
-                <a:solidFill>
-                  <a:srgbClr val="FFFFFF"/>
+              <a:rPr lang="en-US" sz="2600" i="1" dirty="0">
+                <a:solidFill>
+                  <a:srgbClr val="CBD5E1"/>
                 </a:solidFill>
                 <a:latin typeface="Georgia" pitchFamily="34" charset="0"/>
                 <a:ea typeface="Georgia" pitchFamily="34" charset="-122"/>
@@ -6370,7 +6434,7 @@
               </a:rPr>
               <a:t>Thank you</a:t>
             </a:r>
-            <a:endParaRPr lang="en-US" sz="4800" dirty="0"/>
+            <a:endParaRPr lang="en-US" sz="2600" dirty="0"/>
           </a:p>
         </p:txBody>
       </p:sp>
@@ -6382,8 +6446,8 @@
         </p:nvSpPr>
         <p:spPr>
           <a:xfrm>
-            <a:off x="0" y="2377440"/>
-            <a:ext cx="12191695" cy="457200"/>
+            <a:off x="0" y="2103120"/>
+            <a:ext cx="12191695" cy="914400"/>
           </a:xfrm>
           <a:prstGeom prst="rect">
             <a:avLst/>
@@ -6399,17 +6463,17 @@
               <a:buNone/>
             </a:pPr>
             <a:r>
-              <a:rPr lang="en-US" sz="2000" dirty="0">
-                <a:solidFill>
-                  <a:srgbClr val="F59E0B"/>
+              <a:rPr lang="en-US" sz="5000" b="1" dirty="0">
+                <a:solidFill>
+                  <a:srgbClr val="FFFFFF"/>
                 </a:solidFill>
                 <a:latin typeface="Georgia" pitchFamily="34" charset="0"/>
                 <a:ea typeface="Georgia" pitchFamily="34" charset="-122"/>
                 <a:cs typeface="Georgia" pitchFamily="34" charset="-120"/>
               </a:rPr>
-              <a:t>Questions I would like to explore</a:t>
-            </a:r>
-            <a:endParaRPr lang="en-US" sz="2000" dirty="0"/>
+              <a:t>AI agents propose the fix.</a:t>
+            </a:r>
+            <a:endParaRPr lang="en-US" sz="5000" dirty="0"/>
           </a:p>
         </p:txBody>
       </p:sp>
@@ -6421,24 +6485,24 @@
         </p:nvSpPr>
         <p:spPr>
           <a:xfrm>
-            <a:off x="1371600" y="3108960"/>
-            <a:ext cx="9448495" cy="548640"/>
-          </a:xfrm>
-          <a:prstGeom prst="rect">
-            <a:avLst/>
-          </a:prstGeom>
-          <a:noFill/>
-          <a:ln/>
-        </p:spPr>
-        <p:txBody>
-          <a:bodyPr wrap="square" lIns="0" tIns="0" rIns="0" bIns="0" rtlCol="0" anchor="ctr"/>
+            <a:off x="0" y="3154680"/>
+            <a:ext cx="12191695" cy="914400"/>
+          </a:xfrm>
+          <a:prstGeom prst="rect">
+            <a:avLst/>
+          </a:prstGeom>
+          <a:noFill/>
+          <a:ln/>
+        </p:spPr>
+        <p:txBody>
+          <a:bodyPr wrap="square" rtlCol="0" anchor="ctr"/>
           <a:lstStyle/>
           <a:p>
             <a:pPr algn="ctr" indent="0" marL="0">
               <a:buNone/>
             </a:pPr>
             <a:r>
-              <a:rPr lang="en-US" sz="1700" i="1" dirty="0">
+              <a:rPr lang="en-US" sz="3800" dirty="0">
                 <a:solidFill>
                   <a:srgbClr val="FFFFFF"/>
                 </a:solidFill>
@@ -6446,100 +6510,22 @@
                 <a:ea typeface="Georgia" pitchFamily="34" charset="-122"/>
                 <a:cs typeface="Georgia" pitchFamily="34" charset="-120"/>
               </a:rPr>
-              <a:t>“Where does this fit against what we are doing with AI agents internally?”</a:t>
-            </a:r>
-            <a:endParaRPr lang="en-US" sz="1700" dirty="0"/>
-          </a:p>
-        </p:txBody>
-      </p:sp>
-      <p:sp>
-        <p:nvSpPr>
-          <p:cNvPr id="5" name="Text 3"/>
-          <p:cNvSpPr/>
-          <p:nvPr/>
-        </p:nvSpPr>
-        <p:spPr>
-          <a:xfrm>
-            <a:off x="1371600" y="3703320"/>
-            <a:ext cx="9448495" cy="548640"/>
-          </a:xfrm>
-          <a:prstGeom prst="rect">
-            <a:avLst/>
-          </a:prstGeom>
-          <a:noFill/>
-          <a:ln/>
-        </p:spPr>
-        <p:txBody>
-          <a:bodyPr wrap="square" lIns="0" tIns="0" rIns="0" bIns="0" rtlCol="0" anchor="ctr"/>
-          <a:lstStyle/>
-          <a:p>
-            <a:pPr algn="ctr" indent="0" marL="0">
-              <a:buNone/>
-            </a:pPr>
-            <a:r>
-              <a:rPr lang="en-US" sz="1700" i="1" dirty="0">
-                <a:solidFill>
-                  <a:srgbClr val="FFFFFF"/>
-                </a:solidFill>
-                <a:latin typeface="Georgia" pitchFamily="34" charset="0"/>
-                <a:ea typeface="Georgia" pitchFamily="34" charset="-122"/>
-                <a:cs typeface="Georgia" pitchFamily="34" charset="-120"/>
-              </a:rPr>
-              <a:t>“Is the CAB pattern something we should productise further?”</a:t>
-            </a:r>
-            <a:endParaRPr lang="en-US" sz="1700" dirty="0"/>
-          </a:p>
-        </p:txBody>
-      </p:sp>
-      <p:sp>
-        <p:nvSpPr>
-          <p:cNvPr id="6" name="Text 4"/>
-          <p:cNvSpPr/>
-          <p:nvPr/>
-        </p:nvSpPr>
-        <p:spPr>
-          <a:xfrm>
-            <a:off x="1371600" y="4297680"/>
-            <a:ext cx="9448495" cy="548640"/>
-          </a:xfrm>
-          <a:prstGeom prst="rect">
-            <a:avLst/>
-          </a:prstGeom>
-          <a:noFill/>
-          <a:ln/>
-        </p:spPr>
-        <p:txBody>
-          <a:bodyPr wrap="square" lIns="0" tIns="0" rIns="0" bIns="0" rtlCol="0" anchor="ctr"/>
-          <a:lstStyle/>
-          <a:p>
-            <a:pPr algn="ctr" indent="0" marL="0">
-              <a:buNone/>
-            </a:pPr>
-            <a:r>
-              <a:rPr lang="en-US" sz="1700" i="1" dirty="0">
-                <a:solidFill>
-                  <a:srgbClr val="FFFFFF"/>
-                </a:solidFill>
-                <a:latin typeface="Georgia" pitchFamily="34" charset="0"/>
-                <a:ea typeface="Georgia" pitchFamily="34" charset="-122"/>
-                <a:cs typeface="Georgia" pitchFamily="34" charset="-120"/>
-              </a:rPr>
-              <a:t>“Is there a fit with customers starting to deploy AI agents?”</a:t>
-            </a:r>
-            <a:endParaRPr lang="en-US" sz="1700" dirty="0"/>
-          </a:p>
-        </p:txBody>
-      </p:sp>
-      <p:sp>
-        <p:nvSpPr>
-          <p:cNvPr id="7" name="Shape 5"/>
-          <p:cNvSpPr/>
-          <p:nvPr/>
-        </p:nvSpPr>
-        <p:spPr>
-          <a:xfrm>
-            <a:off x="5638648" y="5166360"/>
-            <a:ext cx="914400" cy="36576"/>
+              <a:t>An AI Change Advisory Board decides if it ships.</a:t>
+            </a:r>
+            <a:endParaRPr lang="en-US" sz="3800" dirty="0"/>
+          </a:p>
+        </p:txBody>
+      </p:sp>
+      <p:sp>
+        <p:nvSpPr>
+          <p:cNvPr id="5" name="Shape 3"/>
+          <p:cNvSpPr/>
+          <p:nvPr/>
+        </p:nvSpPr>
+        <p:spPr>
+          <a:xfrm>
+            <a:off x="5547208" y="4480560"/>
+            <a:ext cx="1097280" cy="45720"/>
           </a:xfrm>
           <a:prstGeom prst="rect">
             <a:avLst/>
@@ -6557,26 +6543,29 @@
       </p:sp>
       <p:sp>
         <p:nvSpPr>
-          <p:cNvPr id="8" name="Text 6"/>
-          <p:cNvSpPr/>
-          <p:nvPr/>
-        </p:nvSpPr>
-        <p:spPr>
-          <a:xfrm>
-            <a:off x="0" y="5486400"/>
-            <a:ext cx="12191695" cy="457200"/>
-          </a:xfrm>
-          <a:prstGeom prst="rect">
-            <a:avLst/>
-          </a:prstGeom>
-          <a:noFill/>
-          <a:ln/>
-        </p:spPr>
-        <p:txBody>
-          <a:bodyPr wrap="square" rtlCol="0" anchor="ctr"/>
+          <p:cNvPr id="6" name="Text 4"/>
+          <p:cNvSpPr/>
+          <p:nvPr/>
+        </p:nvSpPr>
+        <p:spPr>
+          <a:xfrm>
+            <a:off x="0" y="4892040"/>
+            <a:ext cx="12191695" cy="1463040"/>
+          </a:xfrm>
+          <a:prstGeom prst="rect">
+            <a:avLst/>
+          </a:prstGeom>
+          <a:noFill/>
+          <a:ln/>
+        </p:spPr>
+        <p:txBody>
+          <a:bodyPr wrap="square" lIns="0" tIns="0" rIns="0" bIns="0" rtlCol="0" anchor="t"/>
           <a:lstStyle/>
           <a:p>
             <a:pPr algn="ctr" indent="0" marL="0">
+              <a:spcAft>
+                <a:spcPts val="200"/>
+              </a:spcAft>
               <a:buNone/>
             </a:pPr>
             <a:r>
@@ -6588,7 +6577,138 @@
                 <a:ea typeface="Calibri" pitchFamily="34" charset="-122"/>
                 <a:cs typeface="Calibri" pitchFamily="34" charset="-120"/>
               </a:rPr>
-              <a:t>github.com/psc0des/ruriskry</a:t>
+              <a:t>Try it</a:t>
+            </a:r>
+            <a:pPr algn="ctr" indent="0" marL="0">
+              <a:spcAft>
+                <a:spcPts val="200"/>
+              </a:spcAft>
+              <a:buNone/>
+            </a:pPr>
+            <a:r>
+              <a:rPr lang="en-US" sz="1600" dirty="0">
+                <a:solidFill>
+                  <a:srgbClr val="FFFFFF"/>
+                </a:solidFill>
+                <a:latin typeface="Calibri" pitchFamily="34" charset="0"/>
+                <a:ea typeface="Calibri" pitchFamily="34" charset="-122"/>
+                <a:cs typeface="Calibri" pitchFamily="34" charset="-120"/>
+              </a:rPr>
+              <a:t>   →   github.com/psc0des/ruriskry</a:t>
+            </a:r>
+            <a:endParaRPr lang="en-US" sz="1600" dirty="0"/>
+          </a:p>
+          <a:p>
+            <a:pPr algn="ctr" indent="0" marL="0">
+              <a:spcAft>
+                <a:spcPts val="200"/>
+              </a:spcAft>
+              <a:buNone/>
+            </a:pPr>
+            <a:r>
+              <a:rPr lang="en-US" sz="600" dirty="0">
+                <a:solidFill>
+                  <a:srgbClr val="000000"/>
+                </a:solidFill>
+                <a:latin typeface="Calibri" pitchFamily="34" charset="0"/>
+                <a:ea typeface="Calibri" pitchFamily="34" charset="-122"/>
+                <a:cs typeface="Calibri" pitchFamily="34" charset="-120"/>
+              </a:rPr>
+              <a:t> </a:t>
+            </a:r>
+            <a:endParaRPr lang="en-US" sz="1600" dirty="0"/>
+          </a:p>
+          <a:p>
+            <a:pPr algn="ctr" indent="0" marL="0">
+              <a:spcAft>
+                <a:spcPts val="200"/>
+              </a:spcAft>
+              <a:buNone/>
+            </a:pPr>
+            <a:r>
+              <a:rPr lang="en-US" sz="1600" b="1" dirty="0">
+                <a:solidFill>
+                  <a:srgbClr val="F59E0B"/>
+                </a:solidFill>
+                <a:latin typeface="Calibri" pitchFamily="34" charset="0"/>
+                <a:ea typeface="Calibri" pitchFamily="34" charset="-122"/>
+                <a:cs typeface="Calibri" pitchFamily="34" charset="-120"/>
+              </a:rPr>
+              <a:t>Dig into the scoring</a:t>
+            </a:r>
+            <a:pPr algn="ctr" indent="0" marL="0">
+              <a:spcAft>
+                <a:spcPts val="200"/>
+              </a:spcAft>
+              <a:buNone/>
+            </a:pPr>
+            <a:r>
+              <a:rPr lang="en-US" sz="1600" dirty="0">
+                <a:solidFill>
+                  <a:srgbClr val="FFFFFF"/>
+                </a:solidFill>
+                <a:latin typeface="Calibri" pitchFamily="34" charset="0"/>
+                <a:ea typeface="Calibri" pitchFamily="34" charset="-122"/>
+                <a:cs typeface="Calibri" pitchFamily="34" charset="-120"/>
+              </a:rPr>
+              <a:t>   →   src/core/governance_engine.py</a:t>
+            </a:r>
+            <a:endParaRPr lang="en-US" sz="1600" dirty="0"/>
+          </a:p>
+          <a:p>
+            <a:pPr algn="ctr" indent="0" marL="0">
+              <a:spcAft>
+                <a:spcPts val="200"/>
+              </a:spcAft>
+              <a:buNone/>
+            </a:pPr>
+            <a:r>
+              <a:rPr lang="en-US" sz="600" dirty="0">
+                <a:solidFill>
+                  <a:srgbClr val="000000"/>
+                </a:solidFill>
+                <a:latin typeface="Calibri" pitchFamily="34" charset="0"/>
+                <a:ea typeface="Calibri" pitchFamily="34" charset="-122"/>
+                <a:cs typeface="Calibri" pitchFamily="34" charset="-120"/>
+              </a:rPr>
+              <a:t> </a:t>
+            </a:r>
+            <a:endParaRPr lang="en-US" sz="1600" dirty="0"/>
+          </a:p>
+          <a:p>
+            <a:pPr algn="ctr" indent="0" marL="0">
+              <a:spcAft>
+                <a:spcPts val="200"/>
+              </a:spcAft>
+              <a:buNone/>
+            </a:pPr>
+            <a:r>
+              <a:rPr lang="en-US" sz="1600" b="1" dirty="0">
+                <a:solidFill>
+                  <a:srgbClr val="F59E0B"/>
+                </a:solidFill>
+                <a:latin typeface="Calibri" pitchFamily="34" charset="0"/>
+                <a:ea typeface="Calibri" pitchFamily="34" charset="-122"/>
+                <a:cs typeface="Calibri" pitchFamily="34" charset="-120"/>
+              </a:rPr>
+              <a:t>Push back</a:t>
+            </a:r>
+            <a:pPr algn="ctr" indent="0" marL="0">
+              <a:spcAft>
+                <a:spcPts val="200"/>
+              </a:spcAft>
+              <a:buNone/>
+            </a:pPr>
+            <a:r>
+              <a:rPr lang="en-US" sz="1600" dirty="0">
+                <a:solidFill>
+                  <a:srgbClr val="FFFFFF"/>
+                </a:solidFill>
+                <a:latin typeface="Calibri" pitchFamily="34" charset="0"/>
+                <a:ea typeface="Calibri" pitchFamily="34" charset="-122"/>
+                <a:cs typeface="Calibri" pitchFamily="34" charset="-120"/>
+              </a:rPr>
+              <a:t>   →   open an issue on GitHub</a:t>
             </a:r>
             <a:endParaRPr lang="en-US" sz="1600" dirty="0"/>
           </a:p>

</xml_diff>

<commit_message>
docs: exec deck — slide 5 now reveals the product with specifics instead of echoing the tagline
Co-Authored-By: Claude Opus 4.7 <noreply@anthropic.com>
</commit_message>
<xml_diff>
--- a/docs/RuriSkry-Exec-Deck.pptx
+++ b/docs/RuriSkry-Exec-Deck.pptx
@@ -8837,8 +8837,8 @@
         </p:nvSpPr>
         <p:spPr>
           <a:xfrm>
-            <a:off x="0" y="1645920"/>
-            <a:ext cx="12191695" cy="822960"/>
+            <a:off x="0" y="1463040"/>
+            <a:ext cx="12191695" cy="914400"/>
           </a:xfrm>
           <a:prstGeom prst="rect">
             <a:avLst/>
@@ -8854,17 +8854,17 @@
               <a:buNone/>
             </a:pPr>
             <a:r>
-              <a:rPr lang="en-US" sz="4400" i="1" dirty="0">
-                <a:solidFill>
-                  <a:srgbClr val="F59E0B"/>
+              <a:rPr lang="en-US" sz="6000" b="1" i="1" dirty="0">
+                <a:solidFill>
+                  <a:srgbClr val="FFFFFF"/>
                 </a:solidFill>
                 <a:latin typeface="Georgia" pitchFamily="34" charset="0"/>
                 <a:ea typeface="Georgia" pitchFamily="34" charset="-122"/>
                 <a:cs typeface="Georgia" pitchFamily="34" charset="-120"/>
               </a:rPr>
-              <a:t>RuriSkry</a:t>
-            </a:r>
-            <a:endParaRPr lang="en-US" sz="4400" dirty="0"/>
+              <a:t>Meet RuriSkry.</a:t>
+            </a:r>
+            <a:endParaRPr lang="en-US" sz="6000" dirty="0"/>
           </a:p>
         </p:txBody>
       </p:sp>
@@ -8876,8 +8876,8 @@
         </p:nvSpPr>
         <p:spPr>
           <a:xfrm>
-            <a:off x="0" y="2834640"/>
-            <a:ext cx="12191695" cy="914400"/>
+            <a:off x="0" y="2697480"/>
+            <a:ext cx="12191695" cy="822960"/>
           </a:xfrm>
           <a:prstGeom prst="rect">
             <a:avLst/>
@@ -8893,71 +8893,32 @@
               <a:buNone/>
             </a:pPr>
             <a:r>
-              <a:rPr lang="en-US" sz="5400" b="1" dirty="0">
-                <a:solidFill>
-                  <a:srgbClr val="FFFFFF"/>
+              <a:rPr lang="en-US" sz="2800" i="1" dirty="0">
+                <a:solidFill>
+                  <a:srgbClr val="F59E0B"/>
                 </a:solidFill>
                 <a:latin typeface="Georgia" pitchFamily="34" charset="0"/>
                 <a:ea typeface="Georgia" pitchFamily="34" charset="-122"/>
                 <a:cs typeface="Georgia" pitchFamily="34" charset="-120"/>
               </a:rPr>
-              <a:t>AI agents propose the fix.</a:t>
-            </a:r>
-            <a:endParaRPr lang="en-US" sz="5400" dirty="0"/>
-          </a:p>
-        </p:txBody>
-      </p:sp>
-      <p:sp>
-        <p:nvSpPr>
-          <p:cNvPr id="4" name="Text 2"/>
-          <p:cNvSpPr/>
-          <p:nvPr/>
-        </p:nvSpPr>
-        <p:spPr>
-          <a:xfrm>
-            <a:off x="0" y="3886200"/>
-            <a:ext cx="12191695" cy="914400"/>
-          </a:xfrm>
-          <a:prstGeom prst="rect">
-            <a:avLst/>
-          </a:prstGeom>
-          <a:noFill/>
-          <a:ln/>
-        </p:spPr>
-        <p:txBody>
-          <a:bodyPr wrap="square" rtlCol="0" anchor="ctr"/>
-          <a:lstStyle/>
-          <a:p>
-            <a:pPr algn="ctr" indent="0" marL="0">
-              <a:buNone/>
-            </a:pPr>
-            <a:r>
-              <a:rPr lang="en-US" sz="4000" dirty="0">
-                <a:solidFill>
-                  <a:srgbClr val="FFFFFF"/>
-                </a:solidFill>
-                <a:latin typeface="Georgia" pitchFamily="34" charset="0"/>
-                <a:ea typeface="Georgia" pitchFamily="34" charset="-122"/>
-                <a:cs typeface="Georgia" pitchFamily="34" charset="-120"/>
-              </a:rPr>
-              <a:t>An AI Change Advisory Board decides if it ships.</a:t>
-            </a:r>
-            <a:endParaRPr lang="en-US" sz="4000" dirty="0"/>
-          </a:p>
-        </p:txBody>
-      </p:sp>
-      <p:sp>
-        <p:nvSpPr>
-          <p:cNvPr id="5" name="Shape 3"/>
-          <p:cNvSpPr/>
-          <p:nvPr/>
-        </p:nvSpPr>
-        <p:spPr>
-          <a:xfrm>
-            <a:off x="6022696" y="5212080"/>
-            <a:ext cx="146304" cy="146304"/>
-          </a:xfrm>
-          <a:prstGeom prst="ellipse">
+              <a:t>A judgment layer between your AI agents and Azure.</a:t>
+            </a:r>
+            <a:endParaRPr lang="en-US" sz="2800" dirty="0"/>
+          </a:p>
+        </p:txBody>
+      </p:sp>
+      <p:sp>
+        <p:nvSpPr>
+          <p:cNvPr id="4" name="Shape 2"/>
+          <p:cNvSpPr/>
+          <p:nvPr/>
+        </p:nvSpPr>
+        <p:spPr>
+          <a:xfrm>
+            <a:off x="5547208" y="3886200"/>
+            <a:ext cx="1097280" cy="45720"/>
+          </a:xfrm>
+          <a:prstGeom prst="rect">
             <a:avLst/>
           </a:prstGeom>
           <a:solidFill>
@@ -8970,6 +8931,154 @@
             <a:prstDash val="solid"/>
           </a:ln>
         </p:spPr>
+      </p:sp>
+      <p:sp>
+        <p:nvSpPr>
+          <p:cNvPr id="5" name="Text 3"/>
+          <p:cNvSpPr/>
+          <p:nvPr/>
+        </p:nvSpPr>
+        <p:spPr>
+          <a:xfrm>
+            <a:off x="1097280" y="4160520"/>
+            <a:ext cx="9997135" cy="1005840"/>
+          </a:xfrm>
+          <a:prstGeom prst="rect">
+            <a:avLst/>
+          </a:prstGeom>
+          <a:noFill/>
+          <a:ln/>
+        </p:spPr>
+        <p:txBody>
+          <a:bodyPr wrap="square" lIns="0" tIns="0" rIns="0" bIns="0" rtlCol="0" anchor="t"/>
+          <a:lstStyle/>
+          <a:p>
+            <a:pPr algn="ctr" indent="0" marL="0">
+              <a:buNone/>
+            </a:pPr>
+            <a:r>
+              <a:rPr lang="en-US" sz="2000" b="1" dirty="0">
+                <a:solidFill>
+                  <a:srgbClr val="FFFFFF"/>
+                </a:solidFill>
+                <a:latin typeface="Calibri" pitchFamily="34" charset="0"/>
+                <a:ea typeface="Calibri" pitchFamily="34" charset="-122"/>
+                <a:cs typeface="Calibri" pitchFamily="34" charset="-120"/>
+              </a:rPr>
+              <a:t>Four agents </a:t>
+            </a:r>
+            <a:pPr algn="ctr" indent="0" marL="0">
+              <a:buNone/>
+            </a:pPr>
+            <a:r>
+              <a:rPr lang="en-US" sz="2000" dirty="0">
+                <a:solidFill>
+                  <a:srgbClr val="CBD5E1"/>
+                </a:solidFill>
+                <a:latin typeface="Calibri" pitchFamily="34" charset="0"/>
+                <a:ea typeface="Calibri" pitchFamily="34" charset="-122"/>
+                <a:cs typeface="Calibri" pitchFamily="34" charset="-120"/>
+              </a:rPr>
+              <a:t>score every proposed action. </a:t>
+            </a:r>
+            <a:pPr algn="ctr" indent="0" marL="0">
+              <a:buNone/>
+            </a:pPr>
+            <a:r>
+              <a:rPr lang="en-US" sz="2000" b="1" dirty="0">
+                <a:solidFill>
+                  <a:srgbClr val="FFFFFF"/>
+                </a:solidFill>
+                <a:latin typeface="Calibri" pitchFamily="34" charset="0"/>
+                <a:ea typeface="Calibri" pitchFamily="34" charset="-122"/>
+                <a:cs typeface="Calibri" pitchFamily="34" charset="-120"/>
+              </a:rPr>
+              <a:t>One verdict </a:t>
+            </a:r>
+            <a:pPr algn="ctr" indent="0" marL="0">
+              <a:buNone/>
+            </a:pPr>
+            <a:r>
+              <a:rPr lang="en-US" sz="2000" dirty="0">
+                <a:solidFill>
+                  <a:srgbClr val="CBD5E1"/>
+                </a:solidFill>
+                <a:latin typeface="Calibri" pitchFamily="34" charset="0"/>
+                <a:ea typeface="Calibri" pitchFamily="34" charset="-122"/>
+                <a:cs typeface="Calibri" pitchFamily="34" charset="-120"/>
+              </a:rPr>
+              <a:t>the execution pipeline enforces. </a:t>
+            </a:r>
+            <a:pPr algn="ctr" indent="0" marL="0">
+              <a:buNone/>
+            </a:pPr>
+            <a:r>
+              <a:rPr lang="en-US" sz="2000" b="1" dirty="0">
+                <a:solidFill>
+                  <a:srgbClr val="FFFFFF"/>
+                </a:solidFill>
+                <a:latin typeface="Calibri" pitchFamily="34" charset="0"/>
+                <a:ea typeface="Calibri" pitchFamily="34" charset="-122"/>
+                <a:cs typeface="Calibri" pitchFamily="34" charset="-120"/>
+              </a:rPr>
+              <a:t>Full audit trail </a:t>
+            </a:r>
+            <a:pPr algn="ctr" indent="0" marL="0">
+              <a:buNone/>
+            </a:pPr>
+            <a:r>
+              <a:rPr lang="en-US" sz="2000" dirty="0">
+                <a:solidFill>
+                  <a:srgbClr val="CBD5E1"/>
+                </a:solidFill>
+                <a:latin typeface="Calibri" pitchFamily="34" charset="0"/>
+                <a:ea typeface="Calibri" pitchFamily="34" charset="-122"/>
+                <a:cs typeface="Calibri" pitchFamily="34" charset="-120"/>
+              </a:rPr>
+              <a:t>for every decision.</a:t>
+            </a:r>
+            <a:endParaRPr lang="en-US" sz="2000" dirty="0"/>
+          </a:p>
+        </p:txBody>
+      </p:sp>
+      <p:sp>
+        <p:nvSpPr>
+          <p:cNvPr id="6" name="Text 4"/>
+          <p:cNvSpPr/>
+          <p:nvPr/>
+        </p:nvSpPr>
+        <p:spPr>
+          <a:xfrm>
+            <a:off x="0" y="5532120"/>
+            <a:ext cx="12191695" cy="457200"/>
+          </a:xfrm>
+          <a:prstGeom prst="rect">
+            <a:avLst/>
+          </a:prstGeom>
+          <a:noFill/>
+          <a:ln/>
+        </p:spPr>
+        <p:txBody>
+          <a:bodyPr wrap="square" rtlCol="0" anchor="ctr"/>
+          <a:lstStyle/>
+          <a:p>
+            <a:pPr algn="ctr" indent="0" marL="0">
+              <a:buNone/>
+            </a:pPr>
+            <a:r>
+              <a:rPr lang="en-US" sz="1700" i="1" dirty="0">
+                <a:solidFill>
+                  <a:srgbClr val="94A3B8"/>
+                </a:solidFill>
+                <a:latin typeface="Georgia" pitchFamily="34" charset="0"/>
+                <a:ea typeface="Georgia" pitchFamily="34" charset="-122"/>
+                <a:cs typeface="Georgia" pitchFamily="34" charset="-120"/>
+              </a:rPr>
+              <a:t>No new process. No new IAM. Just the judgment layer that was missing.</a:t>
+            </a:r>
+            <a:endParaRPr lang="en-US" sz="1700" dirty="0"/>
+          </a:p>
+        </p:txBody>
       </p:sp>
     </p:spTree>
   </p:cSld>

</xml_diff>